<commit_message>
fixed small bugs in lectures 2 and 4
</commit_message>
<xml_diff>
--- a/lectures/04_transformers/04_transformers.pptx
+++ b/lectures/04_transformers/04_transformers.pptx
@@ -148,9 +148,7 @@
 <file path=ppt/revisionInfo.xml><?xml version="1.0" encoding="utf-8"?>
 <p1510:revInfo xmlns:a="http://schemas.openxmlformats.org/drawingml/2006/main" xmlns:r="http://schemas.openxmlformats.org/officeDocument/2006/relationships" xmlns:p1510="http://schemas.microsoft.com/office/powerpoint/2015/10/main">
   <p1510:revLst>
-    <p1510:client id="{6C8DA7BB-0332-C63C-1C36-53EAD1AC1A2B}" v="502" dt="2026-03-24T10:44:07.965"/>
-    <p1510:client id="{D6445606-36CA-19D6-725A-DB6944A1130B}" v="102" dt="2026-03-24T11:20:34.594"/>
-    <p1510:client id="{F67611A0-4684-112F-212A-37799F88C10B}" v="144" dt="2026-03-26T09:12:33.048"/>
+    <p1510:client id="{67E67723-2ADA-7A3D-0672-A2CAFA7DE13C}" v="92" dt="2026-05-26T14:14:45.945"/>
   </p1510:revLst>
 </p1510:revInfo>
 </file>
@@ -16761,7 +16759,7 @@
               <a:buChar char="•"/>
             </a:pPr>
             <a:r>
-              <a:rPr lang="en-US" sz="1800" b="0" strike="noStrike" spc="-1">
+              <a:rPr lang="en-US" sz="1800" b="0" strike="noStrike" spc="-1" dirty="0">
                 <a:solidFill>
                   <a:srgbClr val="003056"/>
                 </a:solidFill>
@@ -16770,7 +16768,7 @@
               <a:t>Attention weights: </a:t>
             </a:r>
             <a:r>
-              <a:rPr lang="en-US" sz="1800" b="0" strike="noStrike" spc="-1" err="1">
+              <a:rPr lang="en-US" sz="1800" b="0" strike="noStrike" spc="-1" dirty="0" err="1">
                 <a:solidFill>
                   <a:srgbClr val="003056"/>
                 </a:solidFill>
@@ -16778,7 +16776,7 @@
               </a:rPr>
               <a:t>softmax</a:t>
             </a:r>
-            <a:endParaRPr lang="de-DE" sz="1800" b="0" strike="noStrike" spc="-1" err="1">
+            <a:endParaRPr lang="de-DE" sz="1800" b="0" strike="noStrike" spc="-1" dirty="0" err="1">
               <a:solidFill>
                 <a:srgbClr val="003056"/>
               </a:solidFill>
@@ -16887,7 +16885,7 @@
               <a:buChar char="•"/>
             </a:pPr>
             <a:r>
-              <a:rPr lang="en-US" sz="2000" b="0" strike="noStrike" spc="-1">
+              <a:rPr lang="en-US" sz="2000" b="0" strike="noStrike" spc="-1" dirty="0">
                 <a:solidFill>
                   <a:srgbClr val="003056"/>
                 </a:solidFill>
@@ -16896,7 +16894,7 @@
               <a:t>Specifically, </a:t>
             </a:r>
             <a:r>
-              <a:rPr lang="en-US" sz="2000" b="1" i="1" strike="noStrike" spc="-1">
+              <a:rPr lang="en-US" sz="2000" b="1" i="1" strike="noStrike" spc="-1" dirty="0">
                 <a:solidFill>
                   <a:srgbClr val="003056"/>
                 </a:solidFill>
@@ -16905,7 +16903,7 @@
               <a:t>q</a:t>
             </a:r>
             <a:r>
-              <a:rPr lang="en-US" sz="2000" b="0" i="1" strike="noStrike" spc="-1" baseline="-25000">
+              <a:rPr lang="en-US" sz="2000" b="0" i="1" strike="noStrike" spc="-1" baseline="-25000" dirty="0">
                 <a:solidFill>
                   <a:srgbClr val="003056"/>
                 </a:solidFill>
@@ -16914,7 +16912,7 @@
               <a:t>i</a:t>
             </a:r>
             <a:r>
-              <a:rPr lang="en-US" sz="2000" b="0" i="1" strike="noStrike" spc="-1">
+              <a:rPr lang="en-US" sz="2000" b="0" i="1" strike="noStrike" spc="-1" dirty="0">
                 <a:solidFill>
                   <a:srgbClr val="003056"/>
                 </a:solidFill>
@@ -16923,7 +16921,7 @@
               <a:t> = </a:t>
             </a:r>
             <a:r>
-              <a:rPr lang="en-US" sz="2000" b="1" i="1" strike="noStrike" spc="-1" err="1">
+              <a:rPr lang="en-US" sz="2000" b="1" i="1" strike="noStrike" spc="-1" dirty="0" err="1">
                 <a:solidFill>
                   <a:srgbClr val="003056"/>
                 </a:solidFill>
@@ -16932,7 +16930,7 @@
               <a:t>W</a:t>
             </a:r>
             <a:r>
-              <a:rPr lang="en-US" sz="2000" b="0" i="1" strike="noStrike" spc="-1" baseline="30000" err="1">
+              <a:rPr lang="en-US" sz="2000" b="0" i="1" strike="noStrike" spc="-1" baseline="30000" dirty="0" err="1">
                 <a:solidFill>
                   <a:srgbClr val="003056"/>
                 </a:solidFill>
@@ -16941,7 +16939,7 @@
               <a:t>Q</a:t>
             </a:r>
             <a:r>
-              <a:rPr lang="en-US" sz="2000" b="1" i="1" strike="noStrike" spc="-1" err="1">
+              <a:rPr lang="en-US" sz="2000" b="1" i="1" strike="noStrike" spc="-1" dirty="0" err="1">
                 <a:solidFill>
                   <a:srgbClr val="003056"/>
                 </a:solidFill>
@@ -16950,7 +16948,7 @@
               <a:t>x</a:t>
             </a:r>
             <a:r>
-              <a:rPr lang="en-US" sz="2000" b="0" i="1" strike="noStrike" spc="-1" baseline="-25000" err="1">
+              <a:rPr lang="en-US" sz="2000" b="0" i="1" strike="noStrike" spc="-1" baseline="-25000" dirty="0" err="1">
                 <a:solidFill>
                   <a:srgbClr val="003056"/>
                 </a:solidFill>
@@ -16959,7 +16957,7 @@
               <a:t>i</a:t>
             </a:r>
             <a:r>
-              <a:rPr lang="en-US" sz="2000" b="0" i="1" strike="noStrike" spc="-1">
+              <a:rPr lang="en-US" sz="2000" b="0" i="1" strike="noStrike" spc="-1" dirty="0">
                 <a:solidFill>
                   <a:srgbClr val="003056"/>
                 </a:solidFill>
@@ -16968,7 +16966,7 @@
               <a:t>,</a:t>
             </a:r>
             <a:r>
-              <a:rPr lang="en-US" sz="2000" b="0" i="1" strike="noStrike" spc="-1" baseline="-25000">
+              <a:rPr lang="en-US" sz="2000" b="0" i="1" strike="noStrike" spc="-1" baseline="-25000" dirty="0">
                 <a:solidFill>
                   <a:srgbClr val="003056"/>
                 </a:solidFill>
@@ -16977,7 +16975,7 @@
               <a:t> </a:t>
             </a:r>
             <a:r>
-              <a:rPr lang="en-US" sz="2000" b="1" i="1" strike="noStrike" spc="-1">
+              <a:rPr lang="en-US" sz="2000" b="1" i="1" strike="noStrike" spc="-1" dirty="0">
                 <a:solidFill>
                   <a:srgbClr val="003056"/>
                 </a:solidFill>
@@ -16986,7 +16984,7 @@
               <a:t>k</a:t>
             </a:r>
             <a:r>
-              <a:rPr lang="en-US" sz="2000" b="0" i="1" strike="noStrike" spc="-1" baseline="-25000">
+              <a:rPr lang="en-US" sz="2000" b="0" i="1" strike="noStrike" spc="-1" baseline="-25000" dirty="0">
                 <a:solidFill>
                   <a:srgbClr val="003056"/>
                 </a:solidFill>
@@ -16995,7 +16993,7 @@
               <a:t>i</a:t>
             </a:r>
             <a:r>
-              <a:rPr lang="en-US" sz="2000" b="0" i="1" strike="noStrike" spc="-1">
+              <a:rPr lang="en-US" sz="2000" b="0" i="1" strike="noStrike" spc="-1" dirty="0">
                 <a:solidFill>
                   <a:srgbClr val="003056"/>
                 </a:solidFill>
@@ -17004,7 +17002,7 @@
               <a:t> = </a:t>
             </a:r>
             <a:r>
-              <a:rPr lang="en-US" sz="2000" b="1" i="1" strike="noStrike" spc="-1" err="1">
+              <a:rPr lang="en-US" sz="2000" b="1" i="1" strike="noStrike" spc="-1" dirty="0" err="1">
                 <a:solidFill>
                   <a:srgbClr val="003056"/>
                 </a:solidFill>
@@ -17013,7 +17011,7 @@
               <a:t>W</a:t>
             </a:r>
             <a:r>
-              <a:rPr lang="en-US" sz="2000" b="0" i="1" strike="noStrike" spc="-1" baseline="30000" err="1">
+              <a:rPr lang="en-US" sz="2000" b="0" i="1" strike="noStrike" spc="-1" baseline="30000" dirty="0" err="1">
                 <a:solidFill>
                   <a:srgbClr val="003056"/>
                 </a:solidFill>
@@ -17022,7 +17020,7 @@
               <a:t>K</a:t>
             </a:r>
             <a:r>
-              <a:rPr lang="en-US" sz="2000" b="1" i="1" strike="noStrike" spc="-1" err="1">
+              <a:rPr lang="en-US" sz="2000" b="1" i="1" strike="noStrike" spc="-1" dirty="0" err="1">
                 <a:solidFill>
                   <a:srgbClr val="003056"/>
                 </a:solidFill>
@@ -17031,7 +17029,7 @@
               <a:t>x</a:t>
             </a:r>
             <a:r>
-              <a:rPr lang="en-US" sz="2000" b="0" i="1" strike="noStrike" spc="-1" baseline="-25000" err="1">
+              <a:rPr lang="en-US" sz="2000" b="0" i="1" strike="noStrike" spc="-1" baseline="-25000" dirty="0" err="1">
                 <a:solidFill>
                   <a:srgbClr val="003056"/>
                 </a:solidFill>
@@ -17040,7 +17038,7 @@
               <a:t>i</a:t>
             </a:r>
             <a:r>
-              <a:rPr lang="en-US" sz="2000" b="0" i="1" strike="noStrike" spc="-1">
+              <a:rPr lang="en-US" sz="2000" b="0" i="1" strike="noStrike" spc="-1" dirty="0">
                 <a:solidFill>
                   <a:srgbClr val="003056"/>
                 </a:solidFill>
@@ -17049,7 +17047,7 @@
               <a:t> </a:t>
             </a:r>
             <a:r>
-              <a:rPr lang="en-US" sz="2000" b="0" strike="noStrike" spc="-1">
+              <a:rPr lang="en-US" sz="2000" b="0" strike="noStrike" spc="-1" dirty="0">
                 <a:solidFill>
                   <a:srgbClr val="003056"/>
                 </a:solidFill>
@@ -17058,7 +17056,7 @@
               <a:t>and </a:t>
             </a:r>
             <a:r>
-              <a:rPr lang="en-US" sz="2000" b="1" strike="noStrike" spc="-1">
+              <a:rPr lang="en-US" sz="2000" b="1" strike="noStrike" spc="-1" dirty="0">
                 <a:solidFill>
                   <a:srgbClr val="003056"/>
                 </a:solidFill>
@@ -17067,7 +17065,7 @@
               <a:t>v</a:t>
             </a:r>
             <a:r>
-              <a:rPr lang="en-US" sz="2000" b="0" i="1" strike="noStrike" spc="-1" baseline="-25000">
+              <a:rPr lang="en-US" sz="2000" b="0" i="1" strike="noStrike" spc="-1" baseline="-25000" dirty="0">
                 <a:solidFill>
                   <a:srgbClr val="003056"/>
                 </a:solidFill>
@@ -17076,7 +17074,7 @@
               <a:t>i</a:t>
             </a:r>
             <a:r>
-              <a:rPr lang="en-US" sz="2000" b="0" i="1" strike="noStrike" spc="-1">
+              <a:rPr lang="en-US" sz="2000" b="0" i="1" strike="noStrike" spc="-1" dirty="0">
                 <a:solidFill>
                   <a:srgbClr val="003056"/>
                 </a:solidFill>
@@ -17085,7 +17083,7 @@
               <a:t> = </a:t>
             </a:r>
             <a:r>
-              <a:rPr lang="en-US" sz="2000" b="1" i="1" strike="noStrike" spc="-1" err="1">
+              <a:rPr lang="en-US" sz="2000" b="1" i="1" strike="noStrike" spc="-1" dirty="0" err="1">
                 <a:solidFill>
                   <a:srgbClr val="003056"/>
                 </a:solidFill>
@@ -17094,7 +17092,7 @@
               <a:t>W</a:t>
             </a:r>
             <a:r>
-              <a:rPr lang="en-US" sz="2000" b="0" i="1" strike="noStrike" spc="-1" baseline="30000" err="1">
+              <a:rPr lang="en-US" sz="2000" b="0" i="1" strike="noStrike" spc="-1" baseline="30000" dirty="0" err="1">
                 <a:solidFill>
                   <a:srgbClr val="003056"/>
                 </a:solidFill>
@@ -17103,7 +17101,7 @@
               <a:t>V</a:t>
             </a:r>
             <a:r>
-              <a:rPr lang="en-US" sz="2000" b="1" i="1" strike="noStrike" spc="-1" err="1">
+              <a:rPr lang="en-US" sz="2000" b="1" i="1" strike="noStrike" spc="-1" dirty="0" err="1">
                 <a:solidFill>
                   <a:srgbClr val="003056"/>
                 </a:solidFill>
@@ -17112,7 +17110,7 @@
               <a:t>x</a:t>
             </a:r>
             <a:r>
-              <a:rPr lang="en-US" sz="2000" b="0" i="1" strike="noStrike" spc="-1" baseline="-25000" err="1">
+              <a:rPr lang="en-US" sz="2000" b="0" i="1" strike="noStrike" spc="-1" baseline="-25000" dirty="0" err="1">
                 <a:solidFill>
                   <a:srgbClr val="003056"/>
                 </a:solidFill>
@@ -17120,7 +17118,78 @@
               </a:rPr>
               <a:t>i</a:t>
             </a:r>
-            <a:endParaRPr lang="de-DE" sz="2000" b="0" strike="noStrike" spc="-1" err="1">
+            <a:r>
+              <a:rPr lang="en-US" sz="2000" i="1" spc="-1" baseline="-25000" dirty="0">
+                <a:solidFill>
+                  <a:srgbClr val="003056"/>
+                </a:solidFill>
+                <a:latin typeface="Calibri"/>
+              </a:rPr>
+              <a:t> </a:t>
+            </a:r>
+            <a:r>
+              <a:rPr lang="en-US" sz="2000" spc="-1" dirty="0">
+                <a:solidFill>
+                  <a:srgbClr val="003056"/>
+                </a:solidFill>
+                <a:latin typeface="Calibri"/>
+              </a:rPr>
+              <a:t>for input </a:t>
+            </a:r>
+            <a:r>
+              <a:rPr lang="en-US" sz="2000" b="1" i="1" spc="-1" dirty="0">
+                <a:solidFill>
+                  <a:srgbClr val="003056"/>
+                </a:solidFill>
+                <a:latin typeface="Calibri"/>
+              </a:rPr>
+              <a:t>x</a:t>
+            </a:r>
+            <a:r>
+              <a:rPr lang="en-US" sz="2000" i="1" spc="-1" dirty="0">
+                <a:solidFill>
+                  <a:srgbClr val="003056"/>
+                </a:solidFill>
+                <a:latin typeface="DejaVu Sans"/>
+                <a:ea typeface="Calibri"/>
+                <a:cs typeface="Calibri"/>
+              </a:rPr>
+              <a:t> </a:t>
+            </a:r>
+            <a:r>
+              <a:rPr lang="az-Cyrl-AZ" sz="2000" i="1" spc="-1" dirty="0">
+                <a:solidFill>
+                  <a:srgbClr val="003056"/>
+                </a:solidFill>
+                <a:latin typeface="Calibri"/>
+                <a:ea typeface="Calibri"/>
+                <a:cs typeface="Calibri"/>
+              </a:rPr>
+              <a:t>Є</a:t>
+            </a:r>
+            <a:r>
+              <a:rPr lang="en-US" sz="2000" i="1" spc="-1" dirty="0">
+                <a:solidFill>
+                  <a:srgbClr val="003056"/>
+                </a:solidFill>
+                <a:latin typeface="Calibri"/>
+                <a:ea typeface="Calibri"/>
+                <a:cs typeface="Calibri"/>
+              </a:rPr>
+              <a:t> R</a:t>
+            </a:r>
+            <a:r>
+              <a:rPr lang="en-US" sz="1800" i="1" spc="-1" baseline="30000" dirty="0">
+                <a:solidFill>
+                  <a:srgbClr val="003056"/>
+                </a:solidFill>
+                <a:latin typeface="Calibri"/>
+                <a:ea typeface="Calibri"/>
+                <a:cs typeface="Calibri"/>
+              </a:rPr>
+              <a:t>Dx1</a:t>
+            </a:r>
+            <a:endParaRPr lang="de-DE" sz="1800" b="0" strike="noStrike" spc="-1" baseline="30000" dirty="0" err="1">
               <a:solidFill>
                 <a:srgbClr val="003056"/>
               </a:solidFill>
@@ -17172,7 +17241,7 @@
               <a:buChar char="•"/>
             </a:pPr>
             <a:r>
-              <a:rPr lang="en-US" sz="1600" b="0" i="1" strike="noStrike" spc="-1">
+              <a:rPr lang="en-US" sz="1600" b="0" i="1" strike="noStrike" spc="-1" dirty="0">
                 <a:solidFill>
                   <a:srgbClr val="003056"/>
                 </a:solidFill>
@@ -17181,7 +17250,7 @@
               <a:t>score(</a:t>
             </a:r>
             <a:r>
-              <a:rPr lang="en-US" sz="1600" b="0" strike="noStrike" spc="-1">
+              <a:rPr lang="en-US" sz="1600" b="0" strike="noStrike" spc="-1" dirty="0">
                 <a:solidFill>
                   <a:srgbClr val="003056"/>
                 </a:solidFill>
@@ -17190,7 +17259,7 @@
               <a:t>input </a:t>
             </a:r>
             <a:r>
-              <a:rPr lang="en-US" sz="1600" b="0" i="1" strike="noStrike" spc="-1" err="1">
+              <a:rPr lang="en-US" sz="1600" b="0" i="1" strike="noStrike" spc="-1" dirty="0" err="1">
                 <a:solidFill>
                   <a:srgbClr val="003056"/>
                 </a:solidFill>
@@ -17199,7 +17268,7 @@
               <a:t>i</a:t>
             </a:r>
             <a:r>
-              <a:rPr lang="en-US" sz="1600" b="0" i="1" strike="noStrike" spc="-1">
+              <a:rPr lang="en-US" sz="1600" b="0" i="1" strike="noStrike" spc="-1" dirty="0">
                 <a:solidFill>
                   <a:srgbClr val="003056"/>
                 </a:solidFill>
@@ -17208,7 +17277,7 @@
               <a:t>, </a:t>
             </a:r>
             <a:r>
-              <a:rPr lang="en-US" sz="1600" b="0" strike="noStrike" spc="-1">
+              <a:rPr lang="en-US" sz="1600" b="0" strike="noStrike" spc="-1" dirty="0">
                 <a:solidFill>
                   <a:srgbClr val="003056"/>
                 </a:solidFill>
@@ -17217,7 +17286,7 @@
               <a:t>input </a:t>
             </a:r>
             <a:r>
-              <a:rPr lang="en-US" sz="1600" b="0" i="1" strike="noStrike" spc="-1">
+              <a:rPr lang="en-US" sz="1600" b="0" i="1" strike="noStrike" spc="-1" dirty="0">
                 <a:solidFill>
                   <a:srgbClr val="003056"/>
                 </a:solidFill>
@@ -17226,7 +17295,7 @@
               <a:t>j) = </a:t>
             </a:r>
             <a:r>
-              <a:rPr lang="en-US" sz="1600" b="1" i="1" strike="noStrike" spc="-1" err="1">
+              <a:rPr lang="en-US" sz="1600" b="1" i="1" strike="noStrike" spc="-1" dirty="0" err="1">
                 <a:solidFill>
                   <a:srgbClr val="003056"/>
                 </a:solidFill>
@@ -17235,7 +17304,7 @@
               <a:t>q</a:t>
             </a:r>
             <a:r>
-              <a:rPr lang="en-US" sz="1600" b="0" i="1" strike="noStrike" spc="-1" baseline="-25000" err="1">
+              <a:rPr lang="en-US" sz="1600" b="0" i="1" strike="noStrike" spc="-1" baseline="-25000" dirty="0" err="1">
                 <a:solidFill>
                   <a:srgbClr val="003056"/>
                 </a:solidFill>
@@ -17244,7 +17313,7 @@
               <a:t>i</a:t>
             </a:r>
             <a:r>
-              <a:rPr lang="en-US" sz="1600" b="0" i="1" strike="noStrike" spc="-1" baseline="30000" err="1">
+              <a:rPr lang="en-US" sz="1600" b="0" i="1" strike="noStrike" spc="-1" baseline="30000" dirty="0" err="1">
                 <a:solidFill>
                   <a:srgbClr val="003056"/>
                 </a:solidFill>
@@ -17253,7 +17322,7 @@
               <a:t>T</a:t>
             </a:r>
             <a:r>
-              <a:rPr lang="en-US" sz="1600" b="1" i="1" strike="noStrike" spc="-1" err="1">
+              <a:rPr lang="en-US" sz="1600" b="1" i="1" strike="noStrike" spc="-1" dirty="0" err="1">
                 <a:solidFill>
                   <a:srgbClr val="003056"/>
                 </a:solidFill>
@@ -17262,7 +17331,7 @@
               <a:t>k</a:t>
             </a:r>
             <a:r>
-              <a:rPr lang="en-US" sz="1600" b="0" i="1" strike="noStrike" spc="-1" baseline="-25000" err="1">
+              <a:rPr lang="en-US" sz="1600" b="0" i="1" strike="noStrike" spc="-1" baseline="-25000" dirty="0" err="1">
                 <a:solidFill>
                   <a:srgbClr val="003056"/>
                 </a:solidFill>
@@ -17270,7 +17339,7 @@
               </a:rPr>
               <a:t>j</a:t>
             </a:r>
-            <a:endParaRPr lang="de-DE" sz="1600" b="0" strike="noStrike" spc="-1" err="1">
+            <a:endParaRPr lang="de-DE" sz="1600" b="0" strike="noStrike" spc="-1" dirty="0" err="1">
               <a:solidFill>
                 <a:srgbClr val="003056"/>
               </a:solidFill>
@@ -17292,7 +17361,7 @@
               <a:buChar char="•"/>
             </a:pPr>
             <a:r>
-              <a:rPr lang="el-GR" sz="1600" b="0" i="1" strike="noStrike" spc="-1">
+              <a:rPr lang="el-GR" sz="1600" b="0" i="1" strike="noStrike" spc="-1" dirty="0">
                 <a:solidFill>
                   <a:srgbClr val="003056"/>
                 </a:solidFill>
@@ -17301,7 +17370,7 @@
               <a:t>α</a:t>
             </a:r>
             <a:r>
-              <a:rPr lang="en-US" sz="1600" b="0" i="1" strike="noStrike" spc="-1" baseline="-25000" err="1">
+              <a:rPr lang="en-US" sz="1600" b="0" i="1" strike="noStrike" spc="-1" baseline="-25000" dirty="0" err="1">
                 <a:solidFill>
                   <a:srgbClr val="003056"/>
                 </a:solidFill>
@@ -17310,7 +17379,7 @@
               <a:t>ij</a:t>
             </a:r>
             <a:r>
-              <a:rPr lang="en-US" sz="1600" i="1" spc="-1" baseline="-25000">
+              <a:rPr lang="en-US" sz="1600" i="1" spc="-1" baseline="-25000" dirty="0">
                 <a:solidFill>
                   <a:srgbClr val="003056"/>
                 </a:solidFill>
@@ -17319,7 +17388,7 @@
               <a:t> </a:t>
             </a:r>
             <a:r>
-              <a:rPr lang="en-US" sz="1600" b="0" i="1" strike="noStrike" spc="-1" baseline="-25000">
+              <a:rPr lang="en-US" sz="1600" b="0" i="1" strike="noStrike" spc="-1" baseline="-25000" dirty="0">
                 <a:solidFill>
                   <a:srgbClr val="003056"/>
                 </a:solidFill>
@@ -17328,7 +17397,7 @@
               <a:t> </a:t>
             </a:r>
             <a:r>
-              <a:rPr lang="en-US" sz="1600" b="0" i="1" strike="noStrike" spc="-1">
+              <a:rPr lang="en-US" sz="1600" b="0" i="1" strike="noStrike" spc="-1" dirty="0">
                 <a:solidFill>
                   <a:srgbClr val="003056"/>
                 </a:solidFill>
@@ -17337,7 +17406,7 @@
               <a:t>= </a:t>
             </a:r>
             <a:r>
-              <a:rPr lang="en-US" sz="1600" b="0" i="1" strike="noStrike" spc="-1" err="1">
+              <a:rPr lang="en-US" sz="1600" b="0" i="1" strike="noStrike" spc="-1" dirty="0" err="1">
                 <a:solidFill>
                   <a:srgbClr val="003056"/>
                 </a:solidFill>
@@ -17346,7 +17415,7 @@
               <a:t>softmax</a:t>
             </a:r>
             <a:r>
-              <a:rPr lang="en-US" sz="1600" b="0" i="1" strike="noStrike" spc="-1">
+              <a:rPr lang="en-US" sz="1600" b="0" i="1" strike="noStrike" spc="-1" dirty="0">
                 <a:solidFill>
                   <a:srgbClr val="003056"/>
                 </a:solidFill>
@@ -17355,7 +17424,7 @@
               <a:t>(score(input </a:t>
             </a:r>
             <a:r>
-              <a:rPr lang="en-US" sz="1600" b="0" i="1" strike="noStrike" spc="-1" err="1">
+              <a:rPr lang="en-US" sz="1600" b="0" i="1" strike="noStrike" spc="-1" dirty="0" err="1">
                 <a:solidFill>
                   <a:srgbClr val="003056"/>
                 </a:solidFill>
@@ -17364,7 +17433,7 @@
               <a:t>i</a:t>
             </a:r>
             <a:r>
-              <a:rPr lang="en-US" sz="1600" b="0" i="1" strike="noStrike" spc="-1">
+              <a:rPr lang="en-US" sz="1600" b="0" i="1" strike="noStrike" spc="-1" dirty="0">
                 <a:solidFill>
                   <a:srgbClr val="003056"/>
                 </a:solidFill>
@@ -17372,7 +17441,7 @@
               </a:rPr>
               <a:t>, input j))</a:t>
             </a:r>
-            <a:endParaRPr lang="de-DE" sz="1600" b="0" strike="noStrike" spc="-1">
+            <a:endParaRPr lang="de-DE" sz="1600" b="0" strike="noStrike" spc="-1" dirty="0">
               <a:solidFill>
                 <a:srgbClr val="003056"/>
               </a:solidFill>
@@ -17394,7 +17463,7 @@
               <a:buChar char="•"/>
             </a:pPr>
             <a:r>
-              <a:rPr lang="en-US" sz="1600" b="1" i="1" strike="noStrike" spc="-1" err="1">
+              <a:rPr lang="en-US" sz="1600" b="1" i="1" strike="noStrike" spc="-1" dirty="0" err="1">
                 <a:solidFill>
                   <a:srgbClr val="003056"/>
                 </a:solidFill>
@@ -17403,7 +17472,7 @@
               <a:t>y</a:t>
             </a:r>
             <a:r>
-              <a:rPr lang="en-US" sz="1600" b="0" i="1" strike="noStrike" spc="-1" baseline="-25000" err="1">
+              <a:rPr lang="en-US" sz="1600" b="0" i="1" strike="noStrike" spc="-1" baseline="-25000" dirty="0" err="1">
                 <a:solidFill>
                   <a:srgbClr val="003056"/>
                 </a:solidFill>
@@ -17412,7 +17481,7 @@
               <a:t>i</a:t>
             </a:r>
             <a:r>
-              <a:rPr lang="en-US" sz="1600" b="0" i="1" strike="noStrike" spc="-1">
+              <a:rPr lang="en-US" sz="1600" b="0" i="1" strike="noStrike" spc="-1" dirty="0">
                 <a:solidFill>
                   <a:srgbClr val="003056"/>
                 </a:solidFill>
@@ -17421,7 +17490,7 @@
               <a:t> = </a:t>
             </a:r>
             <a:r>
-              <a:rPr lang="en-US" sz="1600" b="0" i="1" strike="noStrike" spc="-1" err="1">
+              <a:rPr lang="en-US" sz="1600" b="0" i="1" strike="noStrike" spc="-1" dirty="0" err="1">
                 <a:solidFill>
                   <a:srgbClr val="003056"/>
                 </a:solidFill>
@@ -17430,7 +17499,7 @@
               <a:t>Σ</a:t>
             </a:r>
             <a:r>
-              <a:rPr lang="en-US" sz="1600" b="0" i="1" strike="noStrike" spc="-1" baseline="-25000" err="1">
+              <a:rPr lang="en-US" sz="1600" b="0" i="1" strike="noStrike" spc="-1" baseline="-25000" dirty="0" err="1">
                 <a:solidFill>
                   <a:srgbClr val="003056"/>
                 </a:solidFill>
@@ -17439,7 +17508,7 @@
               <a:t>j</a:t>
             </a:r>
             <a:r>
-              <a:rPr lang="en-US" sz="1600" b="0" i="1" strike="noStrike" spc="-1">
+              <a:rPr lang="en-US" sz="1600" b="0" i="1" strike="noStrike" spc="-1" dirty="0">
                 <a:solidFill>
                   <a:srgbClr val="003056"/>
                 </a:solidFill>
@@ -17448,7 +17517,7 @@
               <a:t> </a:t>
             </a:r>
             <a:r>
-              <a:rPr lang="el-GR" sz="1600" b="0" i="1" strike="noStrike" spc="-1">
+              <a:rPr lang="el-GR" sz="1600" b="0" i="1" strike="noStrike" spc="-1" dirty="0">
                 <a:solidFill>
                   <a:srgbClr val="003056"/>
                 </a:solidFill>
@@ -17457,7 +17526,7 @@
               <a:t>α</a:t>
             </a:r>
             <a:r>
-              <a:rPr lang="en-US" sz="1600" b="0" i="1" strike="noStrike" spc="-1" baseline="-25000" err="1">
+              <a:rPr lang="en-US" sz="1600" b="0" i="1" strike="noStrike" spc="-1" baseline="-25000" dirty="0" err="1">
                 <a:solidFill>
                   <a:srgbClr val="003056"/>
                 </a:solidFill>
@@ -17466,7 +17535,7 @@
               <a:t>ij</a:t>
             </a:r>
             <a:r>
-              <a:rPr lang="en-US" sz="1600" b="0" i="1" strike="noStrike" spc="-1" baseline="-25000">
+              <a:rPr lang="en-US" sz="1600" b="0" i="1" strike="noStrike" spc="-1" baseline="-25000" dirty="0">
                 <a:solidFill>
                   <a:srgbClr val="003056"/>
                 </a:solidFill>
@@ -17475,7 +17544,7 @@
               <a:t> </a:t>
             </a:r>
             <a:r>
-              <a:rPr lang="en-US" sz="1600" b="1" i="1" strike="noStrike" spc="-1" err="1">
+              <a:rPr lang="en-US" sz="1600" b="1" i="1" strike="noStrike" spc="-1" dirty="0" err="1">
                 <a:solidFill>
                   <a:srgbClr val="003056"/>
                 </a:solidFill>
@@ -17484,7 +17553,7 @@
               <a:t>v</a:t>
             </a:r>
             <a:r>
-              <a:rPr lang="en-US" sz="1600" b="0" i="1" strike="noStrike" spc="-1" baseline="-25000" err="1">
+              <a:rPr lang="en-US" sz="1600" b="0" i="1" strike="noStrike" spc="-1" baseline="-25000" dirty="0" err="1">
                 <a:solidFill>
                   <a:srgbClr val="003056"/>
                 </a:solidFill>
@@ -17492,7 +17561,7 @@
               </a:rPr>
               <a:t>j</a:t>
             </a:r>
-            <a:endParaRPr lang="de-DE" sz="1600" b="0" strike="noStrike" spc="-1" err="1">
+            <a:endParaRPr lang="de-DE" sz="1600" b="0" strike="noStrike" spc="-1" dirty="0" err="1">
               <a:solidFill>
                 <a:srgbClr val="003056"/>
               </a:solidFill>
@@ -17514,7 +17583,7 @@
               <a:buChar char="•"/>
             </a:pPr>
             <a:r>
-              <a:rPr lang="en-US" sz="2000" b="0" strike="noStrike" spc="-1">
+              <a:rPr lang="en-US" sz="2000" b="0" strike="noStrike" spc="-1" dirty="0">
                 <a:solidFill>
                   <a:srgbClr val="003056"/>
                 </a:solidFill>
@@ -17523,7 +17592,7 @@
               <a:t>Note that for dot product attention, we require that </a:t>
             </a:r>
             <a:r>
-              <a:rPr lang="en-US" sz="2000" b="1" i="1" strike="noStrike" spc="-1">
+              <a:rPr lang="en-US" sz="2000" b="1" i="1" strike="noStrike" spc="-1" dirty="0">
                 <a:solidFill>
                   <a:srgbClr val="003056"/>
                 </a:solidFill>
@@ -17532,7 +17601,7 @@
               <a:t>W</a:t>
             </a:r>
             <a:r>
-              <a:rPr lang="en-US" sz="2000" b="0" i="1" strike="noStrike" spc="-1" baseline="30000">
+              <a:rPr lang="en-US" sz="2000" b="0" i="1" strike="noStrike" spc="-1" baseline="30000" dirty="0">
                 <a:solidFill>
                   <a:srgbClr val="003056"/>
                 </a:solidFill>
@@ -17541,7 +17610,7 @@
               <a:t>Q, </a:t>
             </a:r>
             <a:r>
-              <a:rPr lang="en-US" sz="2000" b="1" i="1" strike="noStrike" spc="-1">
+              <a:rPr lang="en-US" sz="2000" b="1" i="1" strike="noStrike" spc="-1" dirty="0">
                 <a:solidFill>
                   <a:srgbClr val="003056"/>
                 </a:solidFill>
@@ -17550,7 +17619,7 @@
               <a:t>W</a:t>
             </a:r>
             <a:r>
-              <a:rPr lang="en-US" sz="2000" b="0" i="1" strike="noStrike" spc="-1" baseline="30000">
+              <a:rPr lang="en-US" sz="2000" b="0" i="1" strike="noStrike" spc="-1" baseline="30000" dirty="0">
                 <a:solidFill>
                   <a:srgbClr val="003056"/>
                 </a:solidFill>
@@ -17559,7 +17628,7 @@
               <a:t>K</a:t>
             </a:r>
             <a:r>
-              <a:rPr lang="en-US" sz="2000" b="0" i="1" strike="noStrike" spc="-1">
+              <a:rPr lang="en-US" sz="2000" b="0" i="1" strike="noStrike" spc="-1" dirty="0">
                 <a:solidFill>
                   <a:srgbClr val="003056"/>
                 </a:solidFill>
@@ -17568,7 +17637,7 @@
               <a:t> </a:t>
             </a:r>
             <a:r>
-              <a:rPr lang="az-Cyrl-AZ" sz="2000" b="0" i="1" strike="noStrike" spc="-1">
+              <a:rPr lang="az-Cyrl-AZ" sz="2000" b="0" i="1" strike="noStrike" spc="-1" dirty="0">
                 <a:solidFill>
                   <a:srgbClr val="003056"/>
                 </a:solidFill>
@@ -17577,7 +17646,7 @@
               <a:t>Є</a:t>
             </a:r>
             <a:r>
-              <a:rPr lang="en-US" sz="2000" b="0" i="1" strike="noStrike" spc="-1">
+              <a:rPr lang="en-US" sz="2000" b="0" i="1" strike="noStrike" spc="-1" dirty="0">
                 <a:solidFill>
                   <a:srgbClr val="003056"/>
                 </a:solidFill>
@@ -17586,7 +17655,7 @@
               <a:t> </a:t>
             </a:r>
             <a:r>
-              <a:rPr lang="en-US" sz="2000" b="0" i="1" strike="noStrike" spc="-1" err="1">
+              <a:rPr lang="en-US" sz="2000" i="1" spc="-1" dirty="0" err="1">
                 <a:solidFill>
                   <a:srgbClr val="003056"/>
                 </a:solidFill>
@@ -17595,24 +17664,15 @@
               <a:t>R</a:t>
             </a:r>
             <a:r>
-              <a:rPr lang="en-US" sz="2000" b="0" i="1" strike="noStrike" spc="-1" baseline="30000" err="1">
-                <a:solidFill>
-                  <a:srgbClr val="003056"/>
-                </a:solidFill>
-                <a:latin typeface="Calibri"/>
-              </a:rPr>
-              <a:t>DxD</a:t>
-            </a:r>
-            <a:r>
-              <a:rPr lang="en-US" sz="2000" i="1" spc="-1" baseline="30000">
-                <a:solidFill>
-                  <a:srgbClr val="003056"/>
-                </a:solidFill>
-                <a:latin typeface="Calibri"/>
-              </a:rPr>
-              <a:t>'</a:t>
-            </a:r>
-            <a:endParaRPr lang="de-DE" sz="2000" b="0" strike="noStrike" spc="-1">
+              <a:rPr lang="en-US" sz="2000" i="1" spc="-1" baseline="30000" dirty="0" err="1">
+                <a:solidFill>
+                  <a:srgbClr val="003056"/>
+                </a:solidFill>
+                <a:latin typeface="Calibri"/>
+              </a:rPr>
+              <a:t>D'xD</a:t>
+            </a:r>
+            <a:endParaRPr lang="en-US" sz="2000" b="0" i="1" strike="noStrike" spc="-1" baseline="30000" dirty="0" err="1">
               <a:solidFill>
                 <a:srgbClr val="003056"/>
               </a:solidFill>
@@ -36280,29 +36340,70 @@
               <a:buChar char="•"/>
             </a:pPr>
             <a:r>
-              <a:rPr lang="en-US" sz="1800" b="1" spc="-1" dirty="0">
-                <a:solidFill>
-                  <a:srgbClr val="003056"/>
-                </a:solidFill>
-                <a:latin typeface="Calibri"/>
-              </a:rPr>
-              <a:t>Keys come from decoder tokens, </a:t>
-            </a:r>
-            <a:r>
               <a:rPr lang="en-US" sz="1800" b="1" spc="-1">
                 <a:solidFill>
                   <a:srgbClr val="003056"/>
                 </a:solidFill>
                 <a:latin typeface="Calibri"/>
               </a:rPr>
-              <a:t>queries/values from encoder tokens</a:t>
-            </a:r>
-            <a:endParaRPr lang="en-US" sz="1800" b="1" spc="-1" dirty="0">
+              <a:t>Queries come from decoder tokens, keys/values from encoder tokens </a:t>
+            </a:r>
+            <a:endParaRPr lang="en-US" sz="1800" spc="-1" dirty="0">
               <a:solidFill>
                 <a:srgbClr val="003056"/>
               </a:solidFill>
               <a:latin typeface="Calibri"/>
             </a:endParaRPr>
+          </a:p>
+          <a:p>
+            <a:pPr marL="514350" lvl="1" indent="0">
+              <a:lnSpc>
+                <a:spcPct val="100000"/>
+              </a:lnSpc>
+              <a:spcBef>
+                <a:spcPts val="320"/>
+              </a:spcBef>
+              <a:buClr>
+                <a:srgbClr val="003056"/>
+              </a:buClr>
+              <a:buNone/>
+            </a:pPr>
+            <a:r>
+              <a:rPr lang="en-US" sz="1800" spc="-1">
+                <a:solidFill>
+                  <a:srgbClr val="003056"/>
+                </a:solidFill>
+                <a:latin typeface="Calibri"/>
+              </a:rPr>
+              <a:t>     (see "encoder-decoder attention" in</a:t>
+            </a:r>
+            <a:endParaRPr lang="en-US">
+              <a:solidFill>
+                <a:srgbClr val="000000"/>
+              </a:solidFill>
+              <a:latin typeface="Arial"/>
+            </a:endParaRPr>
+          </a:p>
+          <a:p>
+            <a:pPr marL="514350" lvl="1" indent="0">
+              <a:lnSpc>
+                <a:spcPct val="100000"/>
+              </a:lnSpc>
+              <a:spcBef>
+                <a:spcPts val="320"/>
+              </a:spcBef>
+              <a:buNone/>
+            </a:pPr>
+            <a:r>
+              <a:rPr lang="en-US" sz="1800" spc="-1">
+                <a:solidFill>
+                  <a:srgbClr val="003056"/>
+                </a:solidFill>
+                <a:latin typeface="Calibri"/>
+              </a:rPr>
+              <a:t>      original transformer paper)</a:t>
+            </a:r>
+            <a:endParaRPr lang="en-US"/>
           </a:p>
           <a:p>
             <a:pPr marL="399415" indent="-342900">
@@ -36758,26 +36859,39 @@
                                   </p:childTnLst>
                                 </p:cTn>
                               </p:par>
-                            </p:childTnLst>
-                          </p:cTn>
-                        </p:par>
-                      </p:childTnLst>
-                    </p:cTn>
-                  </p:par>
-                  <p:par>
-                    <p:cTn id="19" fill="hold">
-                      <p:stCondLst>
-                        <p:cond delay="indefinite"/>
-                      </p:stCondLst>
-                      <p:childTnLst>
-                        <p:par>
-                          <p:cTn id="20" fill="hold">
-                            <p:stCondLst>
-                              <p:cond delay="0"/>
-                            </p:stCondLst>
-                            <p:childTnLst>
                               <p:par>
-                                <p:cTn id="21" presetID="1" presetClass="entr" presetSubtype="0" fill="hold" grpId="0" nodeType="clickEffect">
+                                <p:cTn id="19" presetID="1" presetClass="entr" presetSubtype="0" fill="hold" grpId="0" nodeType="withEffect">
+                                  <p:stCondLst>
+                                    <p:cond delay="0"/>
+                                  </p:stCondLst>
+                                  <p:childTnLst>
+                                    <p:set>
+                                      <p:cBhvr>
+                                        <p:cTn id="20" dur="1" fill="hold">
+                                          <p:stCondLst>
+                                            <p:cond delay="0"/>
+                                          </p:stCondLst>
+                                        </p:cTn>
+                                        <p:tgtEl>
+                                          <p:spTgt spid="181">
+                                            <p:txEl>
+                                              <p:pRg st="5" end="5"/>
+                                            </p:txEl>
+                                          </p:spTgt>
+                                        </p:tgtEl>
+                                        <p:attrNameLst>
+                                          <p:attrName>style.visibility</p:attrName>
+                                        </p:attrNameLst>
+                                      </p:cBhvr>
+                                      <p:to>
+                                        <p:strVal val="visible"/>
+                                      </p:to>
+                                    </p:set>
+                                  </p:childTnLst>
+                                </p:cTn>
+                              </p:par>
+                              <p:par>
+                                <p:cTn id="21" presetID="1" presetClass="entr" presetSubtype="0" fill="hold" grpId="0" nodeType="withEffect">
                                   <p:stCondLst>
                                     <p:cond delay="0"/>
                                   </p:stCondLst>
@@ -36792,7 +36906,7 @@
                                         <p:tgtEl>
                                           <p:spTgt spid="181">
                                             <p:txEl>
-                                              <p:pRg st="5" end="5"/>
+                                              <p:pRg st="6" end="6"/>
                                             </p:txEl>
                                           </p:spTgt>
                                         </p:tgtEl>
@@ -36807,39 +36921,26 @@
                                   </p:childTnLst>
                                 </p:cTn>
                               </p:par>
+                            </p:childTnLst>
+                          </p:cTn>
+                        </p:par>
+                      </p:childTnLst>
+                    </p:cTn>
+                  </p:par>
+                  <p:par>
+                    <p:cTn id="23" fill="hold">
+                      <p:stCondLst>
+                        <p:cond delay="indefinite"/>
+                      </p:stCondLst>
+                      <p:childTnLst>
+                        <p:par>
+                          <p:cTn id="24" fill="hold">
+                            <p:stCondLst>
+                              <p:cond delay="0"/>
+                            </p:stCondLst>
+                            <p:childTnLst>
                               <p:par>
-                                <p:cTn id="23" presetID="1" presetClass="entr" presetSubtype="0" fill="hold" grpId="0" nodeType="withEffect">
-                                  <p:stCondLst>
-                                    <p:cond delay="0"/>
-                                  </p:stCondLst>
-                                  <p:childTnLst>
-                                    <p:set>
-                                      <p:cBhvr>
-                                        <p:cTn id="24" dur="1" fill="hold">
-                                          <p:stCondLst>
-                                            <p:cond delay="0"/>
-                                          </p:stCondLst>
-                                        </p:cTn>
-                                        <p:tgtEl>
-                                          <p:spTgt spid="181">
-                                            <p:txEl>
-                                              <p:pRg st="6" end="6"/>
-                                            </p:txEl>
-                                          </p:spTgt>
-                                        </p:tgtEl>
-                                        <p:attrNameLst>
-                                          <p:attrName>style.visibility</p:attrName>
-                                        </p:attrNameLst>
-                                      </p:cBhvr>
-                                      <p:to>
-                                        <p:strVal val="visible"/>
-                                      </p:to>
-                                    </p:set>
-                                  </p:childTnLst>
-                                </p:cTn>
-                              </p:par>
-                              <p:par>
-                                <p:cTn id="25" presetID="1" presetClass="entr" presetSubtype="0" fill="hold" grpId="0" nodeType="withEffect">
+                                <p:cTn id="25" presetID="1" presetClass="entr" presetSubtype="0" fill="hold" grpId="0" nodeType="clickEffect">
                                   <p:stCondLst>
                                     <p:cond delay="0"/>
                                   </p:stCondLst>
@@ -36917,6 +37018,68 @@
                                           <p:spTgt spid="181">
                                             <p:txEl>
                                               <p:pRg st="9" end="9"/>
+                                            </p:txEl>
+                                          </p:spTgt>
+                                        </p:tgtEl>
+                                        <p:attrNameLst>
+                                          <p:attrName>style.visibility</p:attrName>
+                                        </p:attrNameLst>
+                                      </p:cBhvr>
+                                      <p:to>
+                                        <p:strVal val="visible"/>
+                                      </p:to>
+                                    </p:set>
+                                  </p:childTnLst>
+                                </p:cTn>
+                              </p:par>
+                              <p:par>
+                                <p:cTn id="31" presetID="1" presetClass="entr" presetSubtype="0" fill="hold" grpId="0" nodeType="withEffect">
+                                  <p:stCondLst>
+                                    <p:cond delay="0"/>
+                                  </p:stCondLst>
+                                  <p:childTnLst>
+                                    <p:set>
+                                      <p:cBhvr>
+                                        <p:cTn id="32" dur="1" fill="hold">
+                                          <p:stCondLst>
+                                            <p:cond delay="0"/>
+                                          </p:stCondLst>
+                                        </p:cTn>
+                                        <p:tgtEl>
+                                          <p:spTgt spid="181">
+                                            <p:txEl>
+                                              <p:pRg st="10" end="10"/>
+                                            </p:txEl>
+                                          </p:spTgt>
+                                        </p:tgtEl>
+                                        <p:attrNameLst>
+                                          <p:attrName>style.visibility</p:attrName>
+                                        </p:attrNameLst>
+                                      </p:cBhvr>
+                                      <p:to>
+                                        <p:strVal val="visible"/>
+                                      </p:to>
+                                    </p:set>
+                                  </p:childTnLst>
+                                </p:cTn>
+                              </p:par>
+                              <p:par>
+                                <p:cTn id="33" presetID="1" presetClass="entr" presetSubtype="0" fill="hold" grpId="0" nodeType="withEffect">
+                                  <p:stCondLst>
+                                    <p:cond delay="0"/>
+                                  </p:stCondLst>
+                                  <p:childTnLst>
+                                    <p:set>
+                                      <p:cBhvr>
+                                        <p:cTn id="34" dur="1" fill="hold">
+                                          <p:stCondLst>
+                                            <p:cond delay="0"/>
+                                          </p:stCondLst>
+                                        </p:cTn>
+                                        <p:tgtEl>
+                                          <p:spTgt spid="181">
+                                            <p:txEl>
+                                              <p:pRg st="11" end="11"/>
                                             </p:txEl>
                                           </p:spTgt>
                                         </p:tgtEl>
@@ -48512,13 +48675,31 @@
               <a:t>Attention scores: </a:t>
             </a:r>
             <a:r>
-              <a:rPr lang="en-US" sz="2000" b="0" strike="noStrike" spc="-1" dirty="0">
-                <a:solidFill>
-                  <a:srgbClr val="003056"/>
-                </a:solidFill>
-                <a:latin typeface="Calibri"/>
-              </a:rPr>
-              <a:t>how relevant each input is to encoder’s last state</a:t>
+              <a:rPr lang="en-US" sz="2000" b="0" strike="noStrike" spc="-1">
+                <a:solidFill>
+                  <a:srgbClr val="003056"/>
+                </a:solidFill>
+                <a:latin typeface="Calibri"/>
+              </a:rPr>
+              <a:t>how relevant each input is to </a:t>
+            </a:r>
+            <a:r>
+              <a:rPr lang="en-US" sz="2000" spc="-1">
+                <a:solidFill>
+                  <a:srgbClr val="003056"/>
+                </a:solidFill>
+                <a:latin typeface="Calibri"/>
+              </a:rPr>
+              <a:t>decoder’s</a:t>
+            </a:r>
+            <a:r>
+              <a:rPr lang="en-US" sz="2000" b="0" strike="noStrike" spc="-1">
+                <a:solidFill>
+                  <a:srgbClr val="003056"/>
+                </a:solidFill>
+                <a:latin typeface="Calibri"/>
+              </a:rPr>
+              <a:t> last state</a:t>
             </a:r>
             <a:endParaRPr lang="de-DE" sz="2000" b="0" strike="noStrike" spc="-1">
               <a:solidFill>

</xml_diff>